<commit_message>
Updated Open Knowledge Sharing Deliverables Overview
</commit_message>
<xml_diff>
--- a/docs/2_Value_Creation/2a_Product/Open_Knowledge_Sharing/Open_Knowledge_Sharing_v1_Deliverables_Overview.pptx
+++ b/docs/2_Value_Creation/2a_Product/Open_Knowledge_Sharing/Open_Knowledge_Sharing_v1_Deliverables_Overview.pptx
@@ -257,7 +257,7 @@
       <p15:sldGuideLst xmlns:p15="http://schemas.microsoft.com/office/powerpoint/2012/main"/>
     </p:ext>
     <p:ext uri="GoogleSlidesCustomDataVersion2">
-      <go:slidesCustomData xmlns="" xmlns:mc="http://schemas.openxmlformats.org/markup-compatibility/2006" xmlns:mv="urn:schemas-microsoft-com:mac:vml" xmlns:c="http://schemas.openxmlformats.org/drawingml/2006/chart" xmlns:dgm="http://schemas.openxmlformats.org/drawingml/2006/diagram" xmlns:o="urn:schemas-microsoft-com:office:office" xmlns:v="urn:schemas-microsoft-com:vml" xmlns:pvml="urn:schemas-microsoft-com:office:powerpoint" xmlns:com="http://schemas.openxmlformats.org/drawingml/2006/compatibility" xmlns:p14="http://schemas.microsoft.com/office/powerpoint/2010/main" xmlns:p15="http://schemas.microsoft.com/office/powerpoint/2012/main" xmlns:ahyp="http://schemas.microsoft.com/office/drawing/2018/hyperlinkcolor" xmlns:go="http://customooxmlschemas.google.com/" r:id="rId19" roundtripDataSignature="AMtx7mhwEp+Eio5qReXqYqUwMP31HB0A8A=="/>
+      <go:slidesCustomData xmlns:go="http://customooxmlschemas.google.com/" xmlns:ahyp="http://schemas.microsoft.com/office/drawing/2018/hyperlinkcolor" xmlns:p15="http://schemas.microsoft.com/office/powerpoint/2012/main" xmlns:p14="http://schemas.microsoft.com/office/powerpoint/2010/main" xmlns:com="http://schemas.openxmlformats.org/drawingml/2006/compatibility" xmlns:pvml="urn:schemas-microsoft-com:office:powerpoint" xmlns:v="urn:schemas-microsoft-com:vml" xmlns:o="urn:schemas-microsoft-com:office:office" xmlns:dgm="http://schemas.openxmlformats.org/drawingml/2006/diagram" xmlns:c="http://schemas.openxmlformats.org/drawingml/2006/chart" xmlns:mv="urn:schemas-microsoft-com:mac:vml" xmlns:mc="http://schemas.openxmlformats.org/markup-compatibility/2006" xmlns="" r:id="rId19" roundtripDataSignature="AMtx7mhwEp+Eio5qReXqYqUwMP31HB0A8A=="/>
     </p:ext>
   </p:extLst>
 </p:presentation>
@@ -266,7 +266,7 @@
 <file path=ppt/revisionInfo.xml><?xml version="1.0" encoding="utf-8"?>
 <p1510:revInfo xmlns:a="http://schemas.openxmlformats.org/drawingml/2006/main" xmlns:r="http://schemas.openxmlformats.org/officeDocument/2006/relationships" xmlns:p1510="http://schemas.microsoft.com/office/powerpoint/2015/10/main">
   <p1510:revLst>
-    <p1510:client id="{5AC05174-BA9D-FB4D-903E-06F7B3087031}" v="2" dt="2026-08-09T19:40:57.788"/>
+    <p1510:client id="{5AC05174-BA9D-FB4D-903E-06F7B3087031}" v="6" dt="2026-08-13T02:43:55.210"/>
   </p1510:revLst>
 </p1510:revInfo>
 </file>
@@ -276,7 +276,7 @@
   <pc:docChgLst>
     <pc:chgData name="Rich Reba" userId="55db41ab6eb3f845" providerId="LiveId" clId="{0E19DA16-244C-5B50-BE0F-52911DD4CA7E}"/>
     <pc:docChg chg="undo custSel delSld modSld">
-      <pc:chgData name="Rich Reba" userId="55db41ab6eb3f845" providerId="LiveId" clId="{0E19DA16-244C-5B50-BE0F-52911DD4CA7E}" dt="2026-08-13T02:38:10.059" v="849" actId="478"/>
+      <pc:chgData name="Rich Reba" userId="55db41ab6eb3f845" providerId="LiveId" clId="{0E19DA16-244C-5B50-BE0F-52911DD4CA7E}" dt="2026-08-13T02:43:22.215" v="899" actId="20577"/>
       <pc:docMkLst>
         <pc:docMk/>
       </pc:docMkLst>
@@ -295,12 +295,20 @@
           </ac:spMkLst>
         </pc:spChg>
       </pc:sldChg>
-      <pc:sldChg chg="delSp modSp mod">
-        <pc:chgData name="Rich Reba" userId="55db41ab6eb3f845" providerId="LiveId" clId="{0E19DA16-244C-5B50-BE0F-52911DD4CA7E}" dt="2026-08-13T02:38:10.059" v="849" actId="478"/>
+      <pc:sldChg chg="addSp delSp modSp mod">
+        <pc:chgData name="Rich Reba" userId="55db41ab6eb3f845" providerId="LiveId" clId="{0E19DA16-244C-5B50-BE0F-52911DD4CA7E}" dt="2026-08-13T02:42:15.319" v="872" actId="20577"/>
         <pc:sldMkLst>
           <pc:docMk/>
           <pc:sldMk cId="1272635936" sldId="264"/>
         </pc:sldMkLst>
+        <pc:spChg chg="add mod">
+          <ac:chgData name="Rich Reba" userId="55db41ab6eb3f845" providerId="LiveId" clId="{0E19DA16-244C-5B50-BE0F-52911DD4CA7E}" dt="2026-08-13T02:42:15.319" v="872" actId="20577"/>
+          <ac:spMkLst>
+            <pc:docMk/>
+            <pc:sldMk cId="1272635936" sldId="264"/>
+            <ac:spMk id="5" creationId="{279C2539-A599-CF7E-944F-5C23705E39F9}"/>
+          </ac:spMkLst>
+        </pc:spChg>
         <pc:graphicFrameChg chg="del modGraphic">
           <ac:chgData name="Rich Reba" userId="55db41ab6eb3f845" providerId="LiveId" clId="{0E19DA16-244C-5B50-BE0F-52911DD4CA7E}" dt="2026-08-13T02:38:10.059" v="849" actId="478"/>
           <ac:graphicFrameMkLst>
@@ -310,12 +318,20 @@
           </ac:graphicFrameMkLst>
         </pc:graphicFrameChg>
       </pc:sldChg>
-      <pc:sldChg chg="delSp modSp mod">
-        <pc:chgData name="Rich Reba" userId="55db41ab6eb3f845" providerId="LiveId" clId="{0E19DA16-244C-5B50-BE0F-52911DD4CA7E}" dt="2026-08-13T02:32:02.216" v="848" actId="478"/>
+      <pc:sldChg chg="addSp delSp modSp mod">
+        <pc:chgData name="Rich Reba" userId="55db41ab6eb3f845" providerId="LiveId" clId="{0E19DA16-244C-5B50-BE0F-52911DD4CA7E}" dt="2026-08-13T02:43:22.215" v="899" actId="20577"/>
         <pc:sldMkLst>
           <pc:docMk/>
           <pc:sldMk cId="1243007551" sldId="268"/>
         </pc:sldMkLst>
+        <pc:spChg chg="add mod">
+          <ac:chgData name="Rich Reba" userId="55db41ab6eb3f845" providerId="LiveId" clId="{0E19DA16-244C-5B50-BE0F-52911DD4CA7E}" dt="2026-08-13T02:43:22.215" v="899" actId="20577"/>
+          <ac:spMkLst>
+            <pc:docMk/>
+            <pc:sldMk cId="1243007551" sldId="268"/>
+            <ac:spMk id="2" creationId="{E3F46F6A-701E-095B-90D8-0F5F5319F795}"/>
+          </ac:spMkLst>
+        </pc:spChg>
         <pc:spChg chg="mod">
           <ac:chgData name="Rich Reba" userId="55db41ab6eb3f845" providerId="LiveId" clId="{0E19DA16-244C-5B50-BE0F-52911DD4CA7E}" dt="2026-08-13T02:31:58.055" v="847" actId="20577"/>
           <ac:spMkLst>
@@ -17949,6 +17965,44 @@
           </a:p>
         </p:txBody>
       </p:sp>
+      <p:sp>
+        <p:nvSpPr>
+          <p:cNvPr id="5" name="TextBox 4">
+            <a:extLst>
+              <a:ext uri="{FF2B5EF4-FFF2-40B4-BE49-F238E27FC236}">
+                <a16:creationId xmlns:a16="http://schemas.microsoft.com/office/drawing/2014/main" id="{279C2539-A599-CF7E-944F-5C23705E39F9}"/>
+              </a:ext>
+            </a:extLst>
+          </p:cNvPr>
+          <p:cNvSpPr txBox="1"/>
+          <p:nvPr/>
+        </p:nvSpPr>
+        <p:spPr>
+          <a:xfrm>
+            <a:off x="914400" y="1883229"/>
+            <a:ext cx="5460149" cy="307777"/>
+          </a:xfrm>
+          <a:prstGeom prst="rect">
+            <a:avLst/>
+          </a:prstGeom>
+          <a:noFill/>
+        </p:spPr>
+        <p:txBody>
+          <a:bodyPr wrap="none" rtlCol="0">
+            <a:spAutoFit/>
+          </a:bodyPr>
+          <a:lstStyle/>
+          <a:p>
+            <a:r>
+              <a:rPr lang="en-US" dirty="0">
+                <a:hlinkClick r:id="rId3"/>
+              </a:rPr>
+              <a:t>Link to Open_Knowledge_Sharing_v1_Epic-Hypothesis-Statement</a:t>
+            </a:r>
+            <a:endParaRPr lang="en-US" dirty="0"/>
+          </a:p>
+        </p:txBody>
+      </p:sp>
     </p:spTree>
     <p:extLst>
       <p:ext uri="{BB962C8B-B14F-4D97-AF65-F5344CB8AC3E}">
@@ -22015,6 +22069,44 @@
               <a:t>Proprietary and Confidential Information</a:t>
             </a:r>
             <a:endParaRPr dirty="0"/>
+          </a:p>
+        </p:txBody>
+      </p:sp>
+      <p:sp>
+        <p:nvSpPr>
+          <p:cNvPr id="2" name="TextBox 1">
+            <a:extLst>
+              <a:ext uri="{FF2B5EF4-FFF2-40B4-BE49-F238E27FC236}">
+                <a16:creationId xmlns:a16="http://schemas.microsoft.com/office/drawing/2014/main" id="{E3F46F6A-701E-095B-90D8-0F5F5319F795}"/>
+              </a:ext>
+            </a:extLst>
+          </p:cNvPr>
+          <p:cNvSpPr txBox="1"/>
+          <p:nvPr/>
+        </p:nvSpPr>
+        <p:spPr>
+          <a:xfrm>
+            <a:off x="914400" y="1883229"/>
+            <a:ext cx="5032147" cy="307777"/>
+          </a:xfrm>
+          <a:prstGeom prst="rect">
+            <a:avLst/>
+          </a:prstGeom>
+          <a:noFill/>
+        </p:spPr>
+        <p:txBody>
+          <a:bodyPr wrap="none" rtlCol="0">
+            <a:spAutoFit/>
+          </a:bodyPr>
+          <a:lstStyle/>
+          <a:p>
+            <a:r>
+              <a:rPr lang="en-US" dirty="0">
+                <a:hlinkClick r:id="rId3"/>
+              </a:rPr>
+              <a:t>Link to Open_Knowledge_Sharing_v1_Lean_Business_Case</a:t>
+            </a:r>
+            <a:endParaRPr lang="en-US" dirty="0"/>
           </a:p>
         </p:txBody>
       </p:sp>

</xml_diff>